<commit_message>
Update PowerPoint to video version
</commit_message>
<xml_diff>
--- a/presentation/EarthPulse_Presentation.pptx
+++ b/presentation/EarthPulse_Presentation.pptx
@@ -3448,14 +3448,23 @@
       </p:sp>
       <p:pic>
         <p:nvPicPr>
-          <p:cNvPr id="10" name="Picture 9" descr="globe.gif"/>
+          <p:cNvPr id="10" name="globe.mp4">
+            <a:hlinkClick r:id="" action="ppaction://media"/>
+          </p:cNvPr>
           <p:cNvPicPr>
             <a:picLocks noChangeAspect="1"/>
           </p:cNvPicPr>
-          <p:nvPr/>
+          <p:nvPr>
+            <a:videoFile r:link="rId3"/>
+            <p:extLst>
+              <p:ext uri="{DAA4B4D4-6D71-4841-9C94-3DE7FCFB9230}">
+                <p14:media xmlns:p14="http://schemas.microsoft.com/office/powerpoint/2010/main" r:embed="rId2"/>
+              </p:ext>
+            </p:extLst>
+          </p:nvPr>
         </p:nvPicPr>
         <p:blipFill>
-          <a:blip r:embed="rId2"/>
+          <a:blip r:embed="rId4"/>
           <a:stretch>
             <a:fillRect/>
           </a:stretch>
@@ -3517,6 +3526,53 @@
   <p:clrMapOvr>
     <a:masterClrMapping/>
   </p:clrMapOvr>
+  <p:timing>
+    <p:tnLst>
+      <p:par>
+        <p:cTn id="1" dur="indefinite" restart="never" nodeType="tmRoot">
+          <p:childTnLst>
+            <p:video>
+              <p:cMediaNode vol="80000">
+                <p:cTn id="2" fill="hold" display="0">
+                  <p:stCondLst>
+                    <p:cond delay="indefinite"/>
+                  </p:stCondLst>
+                </p:cTn>
+                <p:tgtEl>
+                  <p:spTgt spid="10"/>
+                </p:tgtEl>
+              </p:cMediaNode>
+            </p:video>
+          </p:childTnLst>
+        </p:cTn>
+      </p:par>
+    </p:tnLst>
+  </p:timing>
+  <p:timing>
+    <p:tnLst>
+      <p:par>
+        <p:cTn id="90" dur="indefinite" restart="never" nodeType="tmRoot">
+          <p:childTnLst>
+            <p:videoFile fullScrn="0">
+              <p:cMediaNode vol="0">
+                <p:cTn id="91" fill="hold" repeatCount="indefinite" display="0">
+                  <p:stCondLst>
+                    <p:cond delay="0"/>
+                  </p:stCondLst>
+                  <p:tgtEl>
+                    <p:spTgt spid="10"/>
+                  </p:tgtEl>
+                </p:cTn>
+                <p:tgtEl>
+                  <p:spTgt spid="10"/>
+                </p:tgtEl>
+              </p:cMediaNode>
+            </p:videoFile>
+          </p:childTnLst>
+        </p:cTn>
+      </p:par>
+    </p:tnLst>
+  </p:timing>
 </p:sld>
 </file>
 
@@ -9330,14 +9386,23 @@
       </p:sp>
       <p:pic>
         <p:nvPicPr>
-          <p:cNvPr id="6" name="Picture 5" descr="globe.gif"/>
+          <p:cNvPr id="6" name="globe.mp4">
+            <a:hlinkClick r:id="" action="ppaction://media"/>
+          </p:cNvPr>
           <p:cNvPicPr>
             <a:picLocks noChangeAspect="1"/>
           </p:cNvPicPr>
-          <p:nvPr/>
+          <p:nvPr>
+            <a:videoFile r:link="rId3"/>
+            <p:extLst>
+              <p:ext uri="{DAA4B4D4-6D71-4841-9C94-3DE7FCFB9230}">
+                <p14:media xmlns:p14="http://schemas.microsoft.com/office/powerpoint/2010/main" r:embed="rId2"/>
+              </p:ext>
+            </p:extLst>
+          </p:nvPr>
         </p:nvPicPr>
         <p:blipFill>
-          <a:blip r:embed="rId2"/>
+          <a:blip r:embed="rId4"/>
           <a:stretch>
             <a:fillRect/>
           </a:stretch>
@@ -9621,6 +9686,53 @@
   <p:clrMapOvr>
     <a:masterClrMapping/>
   </p:clrMapOvr>
+  <p:timing>
+    <p:tnLst>
+      <p:par>
+        <p:cTn id="1" dur="indefinite" restart="never" nodeType="tmRoot">
+          <p:childTnLst>
+            <p:video>
+              <p:cMediaNode vol="80000">
+                <p:cTn id="2" fill="hold" display="0">
+                  <p:stCondLst>
+                    <p:cond delay="indefinite"/>
+                  </p:stCondLst>
+                </p:cTn>
+                <p:tgtEl>
+                  <p:spTgt spid="6"/>
+                </p:tgtEl>
+              </p:cMediaNode>
+            </p:video>
+          </p:childTnLst>
+        </p:cTn>
+      </p:par>
+    </p:tnLst>
+  </p:timing>
+  <p:timing>
+    <p:tnLst>
+      <p:par>
+        <p:cTn id="94" dur="indefinite" restart="never" nodeType="tmRoot">
+          <p:childTnLst>
+            <p:videoFile fullScrn="0">
+              <p:cMediaNode vol="0">
+                <p:cTn id="95" fill="hold" repeatCount="indefinite" display="0">
+                  <p:stCondLst>
+                    <p:cond delay="0"/>
+                  </p:stCondLst>
+                  <p:tgtEl>
+                    <p:spTgt spid="6"/>
+                  </p:tgtEl>
+                </p:cTn>
+                <p:tgtEl>
+                  <p:spTgt spid="6"/>
+                </p:tgtEl>
+              </p:cMediaNode>
+            </p:videoFile>
+          </p:childTnLst>
+        </p:cTn>
+      </p:par>
+    </p:tnLst>
+  </p:timing>
 </p:sld>
 </file>
 

</xml_diff>